<commit_message>
docs: add Manager analytics slide to project presentation
</commit_message>
<xml_diff>
--- a/docs/Operational_Pulse_v1.0.5_Presentacion.pptx
+++ b/docs/Operational_Pulse_v1.0.5_Presentacion.pptx
@@ -9,6 +9,7 @@
     <p:sldId id="257" r:id="rId9"/>
     <p:sldId id="258" r:id="rId10"/>
     <p:sldId id="259" r:id="rId11"/>
+    <p:sldId id="261" r:id="rId13"/>
     <p:sldId id="260" r:id="rId12"/>
   </p:sldIdLst>
   <p:sldSz cx="12191695" cy="6858000" type="screen4x3"/>
@@ -787,6 +788,76 @@
           <a:p>
             <a:r>
               <a:t>Los beneficios se describen a partir de funciones implementadas, sin atribuir ahorros porcentuales ni resultados no medidos. El objetivo es ayudar a que cada persona capture su OT y Guardia correctamente en las herramientas corporativas.</a:t>
+            </a:r>
+          </a:p>
+        </p:txBody>
+      </p:sp>
+      <p:sp>
+        <p:nvSpPr>
+          <p:cNvPr id="4" name="Slide Number Placeholder 3"/>
+          <p:cNvSpPr>
+            <a:spLocks noGrp="1"/>
+          </p:cNvSpPr>
+          <p:nvPr>
+            <p:ph type="sldNum" idx="5" sz="quarter"/>
+          </p:nvPr>
+        </p:nvSpPr>
+        <p:spPr/>
+      </p:sp>
+    </p:spTree>
+  </p:cSld>
+  <p:clrMapOvr>
+    <a:masterClrMapping/>
+  </p:clrMapOvr>
+</p:notes>
+</file>
+
+<file path=ppt/notesSlides/notesSlide6.xml><?xml version="1.0" encoding="utf-8"?>
+<p:notes xmlns:a="http://schemas.openxmlformats.org/drawingml/2006/main" xmlns:p="http://schemas.openxmlformats.org/presentationml/2006/main" xmlns:r="http://schemas.openxmlformats.org/officeDocument/2006/relationships">
+  <p:cSld>
+    <p:spTree>
+      <p:nvGrpSpPr>
+        <p:cNvPr id="1" name=""/>
+        <p:cNvGrpSpPr/>
+        <p:nvPr/>
+      </p:nvGrpSpPr>
+      <p:grpSpPr>
+        <a:xfrm>
+          <a:off x="0" y="0"/>
+          <a:ext cx="0" cy="0"/>
+          <a:chOff x="0" y="0"/>
+          <a:chExt cx="0" cy="0"/>
+        </a:xfrm>
+      </p:grpSpPr>
+      <p:sp>
+        <p:nvSpPr>
+          <p:cNvPr id="2" name="Slide Image Placeholder 1"/>
+          <p:cNvSpPr>
+            <a:spLocks noGrp="1"/>
+          </p:cNvSpPr>
+          <p:nvPr>
+            <p:ph type="sldImg" idx="2"/>
+          </p:nvPr>
+        </p:nvSpPr>
+        <p:spPr/>
+      </p:sp>
+      <p:sp>
+        <p:nvSpPr>
+          <p:cNvPr id="3" name="Notes Placeholder 2"/>
+          <p:cNvSpPr>
+            <a:spLocks noGrp="1"/>
+          </p:cNvSpPr>
+          <p:nvPr>
+            <p:ph type="body" idx="3" sz="quarter"/>
+          </p:nvPr>
+        </p:nvSpPr>
+        <p:spPr/>
+        <p:txBody>
+          <a:bodyPr/>
+          <a:lstStyle/>
+          <a:p>
+            <a:r>
+              <a:t>La analítica del Manager unifica historial y métricas: una búsqueda y sus filtros se aplican a los registros, indicadores, comparativas y exportación. Permite comparar dos o más meses, revisar distribución por Grupo y Técnico, y consultar el detalle. Sólo las horas aprobadas suman al total; la Guardia neta descuenta OT coincidente y los solapamientos no se duplican. El ejemplo ilustrado viene del entorno de pruebas: la búsqueda CHG-ALPHA tiene dos horas aprobadas en enero, tres en febrero y un registro pendiente en marzo que no suma horas. Los permisos se limitan al equipo bajo su responsabilidad.</a:t>
             </a:r>
           </a:p>
         </p:txBody>
@@ -4003,7 +4074,7 @@
               </a:defRPr>
             </a:pPr>
             <a:r>
-              <a:t>1 / 5</a:t>
+              <a:t>1 / 6</a:t>
             </a:r>
           </a:p>
         </p:txBody>
@@ -4954,7 +5025,7 @@
               </a:defRPr>
             </a:pPr>
             <a:r>
-              <a:t>2 / 5</a:t>
+              <a:t>2 / 6</a:t>
             </a:r>
           </a:p>
         </p:txBody>
@@ -6550,7 +6621,7 @@
               </a:defRPr>
             </a:pPr>
             <a:r>
-              <a:t>3 / 5</a:t>
+              <a:t>3 / 6</a:t>
             </a:r>
           </a:p>
         </p:txBody>
@@ -7347,7 +7418,7 @@
               </a:defRPr>
             </a:pPr>
             <a:r>
-              <a:t>4 / 5</a:t>
+              <a:t>4 / 6</a:t>
             </a:r>
           </a:p>
         </p:txBody>
@@ -8113,7 +8184,7 @@
               </a:defRPr>
             </a:pPr>
             <a:r>
-              <a:t>5 / 5</a:t>
+              <a:t>6 / 6</a:t>
             </a:r>
           </a:p>
         </p:txBody>
@@ -8819,6 +8890,1262 @@
             </a:pPr>
             <a:r>
               <a:t>Autores: Samuel Alejandro Díaz Chávez · Francisco Cervantes Marquez</a:t>
+            </a:r>
+          </a:p>
+        </p:txBody>
+      </p:sp>
+    </p:spTree>
+  </p:cSld>
+  <p:clrMapOvr>
+    <a:masterClrMapping/>
+  </p:clrMapOvr>
+</p:sld>
+</file>
+
+<file path=ppt/slides/slide6.xml><?xml version="1.0" encoding="utf-8"?>
+<p:sld xmlns:a="http://schemas.openxmlformats.org/drawingml/2006/main" xmlns:p="http://schemas.openxmlformats.org/presentationml/2006/main" xmlns:r="http://schemas.openxmlformats.org/officeDocument/2006/relationships">
+  <p:cSld>
+    <p:bg>
+      <p:bgPr>
+        <a:solidFill>
+          <a:srgbClr val="FFFFFF"/>
+        </a:solidFill>
+        <a:effectLst/>
+      </p:bgPr>
+    </p:bg>
+    <p:spTree>
+      <p:nvGrpSpPr>
+        <p:cNvPr id="1" name=""/>
+        <p:cNvGrpSpPr/>
+        <p:nvPr/>
+      </p:nvGrpSpPr>
+      <p:grpSpPr/>
+      <p:pic>
+        <p:nvPicPr>
+          <p:cNvPr id="2" name="Picture 1" descr="image.png"/>
+          <p:cNvPicPr>
+            <a:picLocks noChangeAspect="1"/>
+          </p:cNvPicPr>
+          <p:nvPr/>
+        </p:nvPicPr>
+        <p:blipFill>
+          <a:blip r:embed="rId2"/>
+          <a:stretch>
+            <a:fillRect/>
+          </a:stretch>
+        </p:blipFill>
+        <p:spPr>
+          <a:xfrm>
+            <a:off x="502920" y="292608"/>
+            <a:ext cx="320040" cy="320040"/>
+          </a:xfrm>
+          <a:prstGeom prst="rect">
+            <a:avLst/>
+          </a:prstGeom>
+        </p:spPr>
+      </p:pic>
+      <p:sp>
+        <p:nvSpPr>
+          <p:cNvPr id="3" name="TextBox 2"/>
+          <p:cNvSpPr txBox="1"/>
+          <p:nvPr/>
+        </p:nvSpPr>
+        <p:spPr>
+          <a:xfrm>
+            <a:off x="905256" y="329184"/>
+            <a:ext cx="4572000" cy="274320"/>
+          </a:xfrm>
+          <a:prstGeom prst="rect">
+            <a:avLst/>
+          </a:prstGeom>
+          <a:noFill/>
+        </p:spPr>
+        <p:txBody>
+          <a:bodyPr wrap="square" lIns="0" rIns="0" tIns="0" bIns="0">
+            <a:spAutoFit/>
+          </a:bodyPr>
+          <a:lstStyle/>
+          <a:p>
+            <a:pPr>
+              <a:spcAft>
+                <a:spcPts val="800"/>
+              </a:spcAft>
+              <a:defRPr sz="1100" b="1">
+                <a:solidFill>
+                  <a:srgbClr val="173653"/>
+                </a:solidFill>
+                <a:latin typeface="Aptos"/>
+              </a:defRPr>
+            </a:pPr>
+            <a:r>
+              <a:t>OPERATIONAL PULSE</a:t>
+            </a:r>
+          </a:p>
+        </p:txBody>
+      </p:sp>
+      <p:pic>
+        <p:nvPicPr>
+          <p:cNvPr id="4" name="Picture 3" descr="image.png"/>
+          <p:cNvPicPr>
+            <a:picLocks noChangeAspect="1"/>
+          </p:cNvPicPr>
+          <p:nvPr/>
+        </p:nvPicPr>
+        <p:blipFill>
+          <a:blip r:embed="rId3"/>
+          <a:stretch>
+            <a:fillRect/>
+          </a:stretch>
+        </p:blipFill>
+        <p:spPr>
+          <a:xfrm>
+            <a:off x="10698480" y="310896"/>
+            <a:ext cx="950976" cy="285292"/>
+          </a:xfrm>
+          <a:prstGeom prst="rect">
+            <a:avLst/>
+          </a:prstGeom>
+        </p:spPr>
+      </p:pic>
+      <p:sp>
+        <p:nvSpPr>
+          <p:cNvPr id="5" name="Rectangle 4"/>
+          <p:cNvSpPr/>
+          <p:nvPr/>
+        </p:nvSpPr>
+        <p:spPr>
+          <a:xfrm>
+            <a:off x="502920" y="6455664"/>
+            <a:ext cx="11173968" cy="11887"/>
+          </a:xfrm>
+          <a:prstGeom prst="rect">
+            <a:avLst/>
+          </a:prstGeom>
+          <a:solidFill>
+            <a:srgbClr val="DFE9F0"/>
+          </a:solidFill>
+          <a:ln>
+            <a:noFill/>
+          </a:ln>
+        </p:spPr>
+        <p:style>
+          <a:lnRef idx="1">
+            <a:schemeClr val="accent1"/>
+          </a:lnRef>
+          <a:fillRef idx="3">
+            <a:schemeClr val="accent1"/>
+          </a:fillRef>
+          <a:effectRef idx="2">
+            <a:schemeClr val="accent1"/>
+          </a:effectRef>
+          <a:fontRef idx="minor">
+            <a:schemeClr val="lt1"/>
+          </a:fontRef>
+        </p:style>
+        <p:txBody>
+          <a:bodyPr rtlCol="0" anchor="ctr"/>
+          <a:lstStyle/>
+          <a:p>
+            <a:pPr algn="ctr"/>
+          </a:p>
+        </p:txBody>
+      </p:sp>
+      <p:sp>
+        <p:nvSpPr>
+          <p:cNvPr id="6" name="TextBox 5"/>
+          <p:cNvSpPr txBox="1"/>
+          <p:nvPr/>
+        </p:nvSpPr>
+        <p:spPr>
+          <a:xfrm>
+            <a:off x="530352" y="6565392"/>
+            <a:ext cx="7315200" cy="164592"/>
+          </a:xfrm>
+          <a:prstGeom prst="rect">
+            <a:avLst/>
+          </a:prstGeom>
+          <a:noFill/>
+        </p:spPr>
+        <p:txBody>
+          <a:bodyPr wrap="square" lIns="0" rIns="0" tIns="0" bIns="0">
+            <a:spAutoFit/>
+          </a:bodyPr>
+          <a:lstStyle/>
+          <a:p>
+            <a:pPr>
+              <a:spcAft>
+                <a:spcPts val="800"/>
+              </a:spcAft>
+              <a:defRPr sz="900" b="0">
+                <a:solidFill>
+                  <a:srgbClr val="718A9B"/>
+                </a:solidFill>
+                <a:latin typeface="Aptos"/>
+              </a:defRPr>
+            </a:pPr>
+            <a:r>
+              <a:t>Operational Pulse · v1.0.5 · Presentación del proyecto</a:t>
+            </a:r>
+          </a:p>
+        </p:txBody>
+      </p:sp>
+      <p:sp>
+        <p:nvSpPr>
+          <p:cNvPr id="7" name="TextBox 6"/>
+          <p:cNvSpPr txBox="1"/>
+          <p:nvPr/>
+        </p:nvSpPr>
+        <p:spPr>
+          <a:xfrm>
+            <a:off x="10972800" y="6556248"/>
+            <a:ext cx="640080" cy="182880"/>
+          </a:xfrm>
+          <a:prstGeom prst="rect">
+            <a:avLst/>
+          </a:prstGeom>
+          <a:noFill/>
+        </p:spPr>
+        <p:txBody>
+          <a:bodyPr wrap="square" lIns="0" rIns="0" tIns="0" bIns="0">
+            <a:spAutoFit/>
+          </a:bodyPr>
+          <a:lstStyle/>
+          <a:p>
+            <a:pPr algn="r">
+              <a:spcAft>
+                <a:spcPts val="800"/>
+              </a:spcAft>
+              <a:defRPr sz="900" b="0">
+                <a:solidFill>
+                  <a:srgbClr val="718A9B"/>
+                </a:solidFill>
+                <a:latin typeface="Aptos"/>
+              </a:defRPr>
+            </a:pPr>
+            <a:r>
+              <a:t>5 / 6</a:t>
+            </a:r>
+          </a:p>
+        </p:txBody>
+      </p:sp>
+      <p:sp>
+        <p:nvSpPr>
+          <p:cNvPr id="8" name="TextBox 7"/>
+          <p:cNvSpPr txBox="1"/>
+          <p:nvPr/>
+        </p:nvSpPr>
+        <p:spPr>
+          <a:xfrm>
+            <a:off x="548640" y="941832"/>
+            <a:ext cx="11064240" cy="640080"/>
+          </a:xfrm>
+          <a:prstGeom prst="rect">
+            <a:avLst/>
+          </a:prstGeom>
+          <a:noFill/>
+        </p:spPr>
+        <p:txBody>
+          <a:bodyPr wrap="square" lIns="0" rIns="0" tIns="0" bIns="0">
+            <a:spAutoFit/>
+          </a:bodyPr>
+          <a:lstStyle/>
+          <a:p>
+            <a:pPr>
+              <a:spcAft>
+                <a:spcPts val="800"/>
+              </a:spcAft>
+              <a:defRPr sz="3000" b="1">
+                <a:solidFill>
+                  <a:srgbClr val="173653"/>
+                </a:solidFill>
+                <a:latin typeface="Aptos"/>
+              </a:defRPr>
+            </a:pPr>
+            <a:r>
+              <a:t>Analítica para decidir y gestionar al equipo.</a:t>
+            </a:r>
+          </a:p>
+        </p:txBody>
+      </p:sp>
+      <p:sp>
+        <p:nvSpPr>
+          <p:cNvPr id="9" name="TextBox 8"/>
+          <p:cNvSpPr txBox="1"/>
+          <p:nvPr/>
+        </p:nvSpPr>
+        <p:spPr>
+          <a:xfrm>
+            <a:off x="566928" y="1609344"/>
+            <a:ext cx="10881360" cy="457200"/>
+          </a:xfrm>
+          <a:prstGeom prst="rect">
+            <a:avLst/>
+          </a:prstGeom>
+          <a:noFill/>
+        </p:spPr>
+        <p:txBody>
+          <a:bodyPr wrap="square" lIns="0" rIns="0" tIns="0" bIns="0">
+            <a:spAutoFit/>
+          </a:bodyPr>
+          <a:lstStyle/>
+          <a:p>
+            <a:pPr>
+              <a:spcAft>
+                <a:spcPts val="800"/>
+              </a:spcAft>
+              <a:defRPr sz="1600" b="0">
+                <a:solidFill>
+                  <a:srgbClr val="718A9B"/>
+                </a:solidFill>
+                <a:latin typeface="Aptos"/>
+              </a:defRPr>
+            </a:pPr>
+            <a:r>
+              <a:t>Historial y métricas conectados a la misma búsqueda.</a:t>
+            </a:r>
+          </a:p>
+        </p:txBody>
+      </p:sp>
+      <p:sp>
+        <p:nvSpPr>
+          <p:cNvPr id="10" name="Rounded Rectangle 9"/>
+          <p:cNvSpPr/>
+          <p:nvPr/>
+        </p:nvSpPr>
+        <p:spPr>
+          <a:xfrm>
+            <a:off x="548640" y="2221992"/>
+            <a:ext cx="6995160" cy="3538728"/>
+          </a:xfrm>
+          <a:prstGeom prst="roundRect">
+            <a:avLst>
+              <a:gd name="adj" fmla="val 12000"/>
+            </a:avLst>
+          </a:prstGeom>
+          <a:solidFill>
+            <a:srgbClr val="F3F7FB"/>
+          </a:solidFill>
+          <a:ln>
+            <a:solidFill>
+              <a:srgbClr val="DFE9F0"/>
+            </a:solidFill>
+          </a:ln>
+        </p:spPr>
+        <p:style>
+          <a:lnRef idx="1">
+            <a:schemeClr val="accent1"/>
+          </a:lnRef>
+          <a:fillRef idx="3">
+            <a:schemeClr val="accent1"/>
+          </a:fillRef>
+          <a:effectRef idx="2">
+            <a:schemeClr val="accent1"/>
+          </a:effectRef>
+          <a:fontRef idx="minor">
+            <a:schemeClr val="lt1"/>
+          </a:fontRef>
+        </p:style>
+        <p:txBody>
+          <a:bodyPr rtlCol="0" anchor="ctr"/>
+          <a:lstStyle/>
+          <a:p>
+            <a:pPr algn="ctr"/>
+          </a:p>
+        </p:txBody>
+      </p:sp>
+      <p:pic>
+        <p:nvPicPr>
+          <p:cNvPr id="11" name="Picture 10" descr="manager-analytics.png"/>
+          <p:cNvPicPr>
+            <a:picLocks noChangeAspect="1"/>
+          </p:cNvPicPr>
+          <p:nvPr/>
+        </p:nvPicPr>
+        <p:blipFill>
+          <a:blip r:embed="rId4"/>
+          <a:stretch>
+            <a:fillRect/>
+          </a:stretch>
+        </p:blipFill>
+        <p:spPr>
+          <a:xfrm>
+            <a:off x="768096" y="2441448"/>
+            <a:ext cx="6547104" cy="2361371"/>
+          </a:xfrm>
+          <a:prstGeom prst="rect">
+            <a:avLst/>
+          </a:prstGeom>
+        </p:spPr>
+      </p:pic>
+      <p:sp>
+        <p:nvSpPr>
+          <p:cNvPr id="12" name="Rounded Rectangle 11"/>
+          <p:cNvSpPr/>
+          <p:nvPr/>
+        </p:nvSpPr>
+        <p:spPr>
+          <a:xfrm>
+            <a:off x="859536" y="4956048"/>
+            <a:ext cx="1947672" cy="548640"/>
+          </a:xfrm>
+          <a:prstGeom prst="roundRect">
+            <a:avLst>
+              <a:gd name="adj" fmla="val 12000"/>
+            </a:avLst>
+          </a:prstGeom>
+          <a:solidFill>
+            <a:srgbClr val="FFFFFF"/>
+          </a:solidFill>
+          <a:ln>
+            <a:solidFill>
+              <a:srgbClr val="DFE9F0"/>
+            </a:solidFill>
+          </a:ln>
+        </p:spPr>
+        <p:style>
+          <a:lnRef idx="1">
+            <a:schemeClr val="accent1"/>
+          </a:lnRef>
+          <a:fillRef idx="3">
+            <a:schemeClr val="accent1"/>
+          </a:fillRef>
+          <a:effectRef idx="2">
+            <a:schemeClr val="accent1"/>
+          </a:effectRef>
+          <a:fontRef idx="minor">
+            <a:schemeClr val="lt1"/>
+          </a:fontRef>
+        </p:style>
+        <p:txBody>
+          <a:bodyPr rtlCol="0" anchor="ctr"/>
+          <a:lstStyle/>
+          <a:p>
+            <a:pPr algn="ctr"/>
+          </a:p>
+        </p:txBody>
+      </p:sp>
+      <p:sp>
+        <p:nvSpPr>
+          <p:cNvPr id="13" name="TextBox 12"/>
+          <p:cNvSpPr txBox="1"/>
+          <p:nvPr/>
+        </p:nvSpPr>
+        <p:spPr>
+          <a:xfrm>
+            <a:off x="978407" y="5102352"/>
+            <a:ext cx="850392" cy="219456"/>
+          </a:xfrm>
+          <a:prstGeom prst="rect">
+            <a:avLst/>
+          </a:prstGeom>
+          <a:noFill/>
+        </p:spPr>
+        <p:txBody>
+          <a:bodyPr wrap="square" lIns="0" rIns="0" tIns="0" bIns="0">
+            <a:spAutoFit/>
+          </a:bodyPr>
+          <a:lstStyle/>
+          <a:p>
+            <a:pPr>
+              <a:spcAft>
+                <a:spcPts val="800"/>
+              </a:spcAft>
+              <a:defRPr sz="1200" b="0">
+                <a:solidFill>
+                  <a:srgbClr val="718A9B"/>
+                </a:solidFill>
+                <a:latin typeface="Aptos"/>
+              </a:defRPr>
+            </a:pPr>
+            <a:r>
+              <a:t>Enero</a:t>
+            </a:r>
+          </a:p>
+        </p:txBody>
+      </p:sp>
+      <p:sp>
+        <p:nvSpPr>
+          <p:cNvPr id="14" name="TextBox 13"/>
+          <p:cNvSpPr txBox="1"/>
+          <p:nvPr/>
+        </p:nvSpPr>
+        <p:spPr>
+          <a:xfrm>
+            <a:off x="1856232" y="5029200"/>
+            <a:ext cx="758952" cy="329184"/>
+          </a:xfrm>
+          <a:prstGeom prst="rect">
+            <a:avLst/>
+          </a:prstGeom>
+          <a:noFill/>
+        </p:spPr>
+        <p:txBody>
+          <a:bodyPr wrap="square" lIns="0" rIns="0" tIns="0" bIns="0">
+            <a:spAutoFit/>
+          </a:bodyPr>
+          <a:lstStyle/>
+          <a:p>
+            <a:pPr>
+              <a:spcAft>
+                <a:spcPts val="800"/>
+              </a:spcAft>
+              <a:defRPr sz="2100" b="1">
+                <a:solidFill>
+                  <a:srgbClr val="168F94"/>
+                </a:solidFill>
+                <a:latin typeface="Aptos"/>
+              </a:defRPr>
+            </a:pPr>
+            <a:r>
+              <a:t>2 h</a:t>
+            </a:r>
+          </a:p>
+        </p:txBody>
+      </p:sp>
+      <p:sp>
+        <p:nvSpPr>
+          <p:cNvPr id="15" name="Rounded Rectangle 14"/>
+          <p:cNvSpPr/>
+          <p:nvPr/>
+        </p:nvSpPr>
+        <p:spPr>
+          <a:xfrm>
+            <a:off x="3035808" y="4956048"/>
+            <a:ext cx="1947672" cy="548640"/>
+          </a:xfrm>
+          <a:prstGeom prst="roundRect">
+            <a:avLst>
+              <a:gd name="adj" fmla="val 12000"/>
+            </a:avLst>
+          </a:prstGeom>
+          <a:solidFill>
+            <a:srgbClr val="FFFFFF"/>
+          </a:solidFill>
+          <a:ln>
+            <a:solidFill>
+              <a:srgbClr val="DFE9F0"/>
+            </a:solidFill>
+          </a:ln>
+        </p:spPr>
+        <p:style>
+          <a:lnRef idx="1">
+            <a:schemeClr val="accent1"/>
+          </a:lnRef>
+          <a:fillRef idx="3">
+            <a:schemeClr val="accent1"/>
+          </a:fillRef>
+          <a:effectRef idx="2">
+            <a:schemeClr val="accent1"/>
+          </a:effectRef>
+          <a:fontRef idx="minor">
+            <a:schemeClr val="lt1"/>
+          </a:fontRef>
+        </p:style>
+        <p:txBody>
+          <a:bodyPr rtlCol="0" anchor="ctr"/>
+          <a:lstStyle/>
+          <a:p>
+            <a:pPr algn="ctr"/>
+          </a:p>
+        </p:txBody>
+      </p:sp>
+      <p:sp>
+        <p:nvSpPr>
+          <p:cNvPr id="16" name="TextBox 15"/>
+          <p:cNvSpPr txBox="1"/>
+          <p:nvPr/>
+        </p:nvSpPr>
+        <p:spPr>
+          <a:xfrm>
+            <a:off x="3154679" y="5102352"/>
+            <a:ext cx="850392" cy="219456"/>
+          </a:xfrm>
+          <a:prstGeom prst="rect">
+            <a:avLst/>
+          </a:prstGeom>
+          <a:noFill/>
+        </p:spPr>
+        <p:txBody>
+          <a:bodyPr wrap="square" lIns="0" rIns="0" tIns="0" bIns="0">
+            <a:spAutoFit/>
+          </a:bodyPr>
+          <a:lstStyle/>
+          <a:p>
+            <a:pPr>
+              <a:spcAft>
+                <a:spcPts val="800"/>
+              </a:spcAft>
+              <a:defRPr sz="1200" b="0">
+                <a:solidFill>
+                  <a:srgbClr val="718A9B"/>
+                </a:solidFill>
+                <a:latin typeface="Aptos"/>
+              </a:defRPr>
+            </a:pPr>
+            <a:r>
+              <a:t>Febrero</a:t>
+            </a:r>
+          </a:p>
+        </p:txBody>
+      </p:sp>
+      <p:sp>
+        <p:nvSpPr>
+          <p:cNvPr id="17" name="TextBox 16"/>
+          <p:cNvSpPr txBox="1"/>
+          <p:nvPr/>
+        </p:nvSpPr>
+        <p:spPr>
+          <a:xfrm>
+            <a:off x="4032504" y="5029200"/>
+            <a:ext cx="758952" cy="329184"/>
+          </a:xfrm>
+          <a:prstGeom prst="rect">
+            <a:avLst/>
+          </a:prstGeom>
+          <a:noFill/>
+        </p:spPr>
+        <p:txBody>
+          <a:bodyPr wrap="square" lIns="0" rIns="0" tIns="0" bIns="0">
+            <a:spAutoFit/>
+          </a:bodyPr>
+          <a:lstStyle/>
+          <a:p>
+            <a:pPr>
+              <a:spcAft>
+                <a:spcPts val="800"/>
+              </a:spcAft>
+              <a:defRPr sz="2100" b="1">
+                <a:solidFill>
+                  <a:srgbClr val="168F94"/>
+                </a:solidFill>
+                <a:latin typeface="Aptos"/>
+              </a:defRPr>
+            </a:pPr>
+            <a:r>
+              <a:t>3 h</a:t>
+            </a:r>
+          </a:p>
+        </p:txBody>
+      </p:sp>
+      <p:sp>
+        <p:nvSpPr>
+          <p:cNvPr id="18" name="Rounded Rectangle 17"/>
+          <p:cNvSpPr/>
+          <p:nvPr/>
+        </p:nvSpPr>
+        <p:spPr>
+          <a:xfrm>
+            <a:off x="5212079" y="4956048"/>
+            <a:ext cx="1947672" cy="548640"/>
+          </a:xfrm>
+          <a:prstGeom prst="roundRect">
+            <a:avLst>
+              <a:gd name="adj" fmla="val 12000"/>
+            </a:avLst>
+          </a:prstGeom>
+          <a:solidFill>
+            <a:srgbClr val="FFFFFF"/>
+          </a:solidFill>
+          <a:ln>
+            <a:solidFill>
+              <a:srgbClr val="DFE9F0"/>
+            </a:solidFill>
+          </a:ln>
+        </p:spPr>
+        <p:style>
+          <a:lnRef idx="1">
+            <a:schemeClr val="accent1"/>
+          </a:lnRef>
+          <a:fillRef idx="3">
+            <a:schemeClr val="accent1"/>
+          </a:fillRef>
+          <a:effectRef idx="2">
+            <a:schemeClr val="accent1"/>
+          </a:effectRef>
+          <a:fontRef idx="minor">
+            <a:schemeClr val="lt1"/>
+          </a:fontRef>
+        </p:style>
+        <p:txBody>
+          <a:bodyPr rtlCol="0" anchor="ctr"/>
+          <a:lstStyle/>
+          <a:p>
+            <a:pPr algn="ctr"/>
+          </a:p>
+        </p:txBody>
+      </p:sp>
+      <p:sp>
+        <p:nvSpPr>
+          <p:cNvPr id="19" name="TextBox 18"/>
+          <p:cNvSpPr txBox="1"/>
+          <p:nvPr/>
+        </p:nvSpPr>
+        <p:spPr>
+          <a:xfrm>
+            <a:off x="5330951" y="5102352"/>
+            <a:ext cx="850392" cy="219456"/>
+          </a:xfrm>
+          <a:prstGeom prst="rect">
+            <a:avLst/>
+          </a:prstGeom>
+          <a:noFill/>
+        </p:spPr>
+        <p:txBody>
+          <a:bodyPr wrap="square" lIns="0" rIns="0" tIns="0" bIns="0">
+            <a:spAutoFit/>
+          </a:bodyPr>
+          <a:lstStyle/>
+          <a:p>
+            <a:pPr>
+              <a:spcAft>
+                <a:spcPts val="800"/>
+              </a:spcAft>
+              <a:defRPr sz="1200" b="0">
+                <a:solidFill>
+                  <a:srgbClr val="718A9B"/>
+                </a:solidFill>
+                <a:latin typeface="Aptos"/>
+              </a:defRPr>
+            </a:pPr>
+            <a:r>
+              <a:t>Marzo</a:t>
+            </a:r>
+          </a:p>
+        </p:txBody>
+      </p:sp>
+      <p:sp>
+        <p:nvSpPr>
+          <p:cNvPr id="20" name="TextBox 19"/>
+          <p:cNvSpPr txBox="1"/>
+          <p:nvPr/>
+        </p:nvSpPr>
+        <p:spPr>
+          <a:xfrm>
+            <a:off x="6208775" y="5029200"/>
+            <a:ext cx="758952" cy="329184"/>
+          </a:xfrm>
+          <a:prstGeom prst="rect">
+            <a:avLst/>
+          </a:prstGeom>
+          <a:noFill/>
+        </p:spPr>
+        <p:txBody>
+          <a:bodyPr wrap="square" lIns="0" rIns="0" tIns="0" bIns="0">
+            <a:spAutoFit/>
+          </a:bodyPr>
+          <a:lstStyle/>
+          <a:p>
+            <a:pPr>
+              <a:spcAft>
+                <a:spcPts val="800"/>
+              </a:spcAft>
+              <a:defRPr sz="2100" b="1">
+                <a:solidFill>
+                  <a:srgbClr val="168F94"/>
+                </a:solidFill>
+                <a:latin typeface="Aptos"/>
+              </a:defRPr>
+            </a:pPr>
+            <a:r>
+              <a:t>0 h</a:t>
+            </a:r>
+          </a:p>
+        </p:txBody>
+      </p:sp>
+      <p:sp>
+        <p:nvSpPr>
+          <p:cNvPr id="21" name="TextBox 20"/>
+          <p:cNvSpPr txBox="1"/>
+          <p:nvPr/>
+        </p:nvSpPr>
+        <p:spPr>
+          <a:xfrm>
+            <a:off x="768096" y="5568696"/>
+            <a:ext cx="6492240" cy="164592"/>
+          </a:xfrm>
+          <a:prstGeom prst="rect">
+            <a:avLst/>
+          </a:prstGeom>
+          <a:noFill/>
+        </p:spPr>
+        <p:txBody>
+          <a:bodyPr wrap="square" lIns="0" rIns="0" tIns="0" bIns="0">
+            <a:spAutoFit/>
+          </a:bodyPr>
+          <a:lstStyle/>
+          <a:p>
+            <a:pPr>
+              <a:spcAft>
+                <a:spcPts val="800"/>
+              </a:spcAft>
+              <a:defRPr sz="1000" b="0">
+                <a:solidFill>
+                  <a:srgbClr val="718A9B"/>
+                </a:solidFill>
+                <a:latin typeface="Aptos"/>
+              </a:defRPr>
+            </a:pPr>
+            <a:r>
+              <a:t>Ejemplo de búsqueda · datos de prueba · horas aprobadas</a:t>
+            </a:r>
+          </a:p>
+        </p:txBody>
+      </p:sp>
+      <p:sp>
+        <p:nvSpPr>
+          <p:cNvPr id="22" name="Rounded Rectangle 21"/>
+          <p:cNvSpPr/>
+          <p:nvPr/>
+        </p:nvSpPr>
+        <p:spPr>
+          <a:xfrm>
+            <a:off x="7872983" y="2221992"/>
+            <a:ext cx="3730752" cy="1069848"/>
+          </a:xfrm>
+          <a:prstGeom prst="roundRect">
+            <a:avLst>
+              <a:gd name="adj" fmla="val 12000"/>
+            </a:avLst>
+          </a:prstGeom>
+          <a:solidFill>
+            <a:srgbClr val="F5F9FC"/>
+          </a:solidFill>
+          <a:ln>
+            <a:solidFill>
+              <a:srgbClr val="DFE9F0"/>
+            </a:solidFill>
+          </a:ln>
+        </p:spPr>
+        <p:style>
+          <a:lnRef idx="1">
+            <a:schemeClr val="accent1"/>
+          </a:lnRef>
+          <a:fillRef idx="3">
+            <a:schemeClr val="accent1"/>
+          </a:fillRef>
+          <a:effectRef idx="2">
+            <a:schemeClr val="accent1"/>
+          </a:effectRef>
+          <a:fontRef idx="minor">
+            <a:schemeClr val="lt1"/>
+          </a:fontRef>
+        </p:style>
+        <p:txBody>
+          <a:bodyPr rtlCol="0" anchor="ctr"/>
+          <a:lstStyle/>
+          <a:p>
+            <a:pPr algn="ctr"/>
+          </a:p>
+        </p:txBody>
+      </p:sp>
+      <p:sp>
+        <p:nvSpPr>
+          <p:cNvPr id="23" name="TextBox 22"/>
+          <p:cNvSpPr txBox="1"/>
+          <p:nvPr/>
+        </p:nvSpPr>
+        <p:spPr>
+          <a:xfrm>
+            <a:off x="8083296" y="2350008"/>
+            <a:ext cx="3291840" cy="283464"/>
+          </a:xfrm>
+          <a:prstGeom prst="rect">
+            <a:avLst/>
+          </a:prstGeom>
+          <a:noFill/>
+        </p:spPr>
+        <p:txBody>
+          <a:bodyPr wrap="square" lIns="0" rIns="0" tIns="0" bIns="0">
+            <a:spAutoFit/>
+          </a:bodyPr>
+          <a:lstStyle/>
+          <a:p>
+            <a:pPr>
+              <a:spcAft>
+                <a:spcPts val="800"/>
+              </a:spcAft>
+              <a:defRPr sz="1800" b="1">
+                <a:solidFill>
+                  <a:srgbClr val="173653"/>
+                </a:solidFill>
+                <a:latin typeface="Aptos"/>
+              </a:defRPr>
+            </a:pPr>
+            <a:r>
+              <a:t>Buscar y filtrar</a:t>
+            </a:r>
+          </a:p>
+        </p:txBody>
+      </p:sp>
+      <p:sp>
+        <p:nvSpPr>
+          <p:cNvPr id="24" name="TextBox 23"/>
+          <p:cNvSpPr txBox="1"/>
+          <p:nvPr/>
+        </p:nvSpPr>
+        <p:spPr>
+          <a:xfrm>
+            <a:off x="8083296" y="2715768"/>
+            <a:ext cx="3291840" cy="530352"/>
+          </a:xfrm>
+          <a:prstGeom prst="rect">
+            <a:avLst/>
+          </a:prstGeom>
+          <a:noFill/>
+        </p:spPr>
+        <p:txBody>
+          <a:bodyPr wrap="square" lIns="0" rIns="0" tIns="0" bIns="0">
+            <a:spAutoFit/>
+          </a:bodyPr>
+          <a:lstStyle/>
+          <a:p>
+            <a:pPr>
+              <a:spcAft>
+                <a:spcPts val="800"/>
+              </a:spcAft>
+              <a:defRPr sz="1300" b="0">
+                <a:solidFill>
+                  <a:srgbClr val="31566F"/>
+                </a:solidFill>
+                <a:latin typeface="Aptos"/>
+              </a:defRPr>
+            </a:pPr>
+            <a:r>
+              <a:t>Referencia, Técnico, Grupo, tipo y estado del registro.</a:t>
+            </a:r>
+          </a:p>
+        </p:txBody>
+      </p:sp>
+      <p:sp>
+        <p:nvSpPr>
+          <p:cNvPr id="25" name="Rounded Rectangle 24"/>
+          <p:cNvSpPr/>
+          <p:nvPr/>
+        </p:nvSpPr>
+        <p:spPr>
+          <a:xfrm>
+            <a:off x="7872983" y="3447288"/>
+            <a:ext cx="3730752" cy="1069848"/>
+          </a:xfrm>
+          <a:prstGeom prst="roundRect">
+            <a:avLst>
+              <a:gd name="adj" fmla="val 12000"/>
+            </a:avLst>
+          </a:prstGeom>
+          <a:solidFill>
+            <a:srgbClr val="F5F9FC"/>
+          </a:solidFill>
+          <a:ln>
+            <a:solidFill>
+              <a:srgbClr val="DFE9F0"/>
+            </a:solidFill>
+          </a:ln>
+        </p:spPr>
+        <p:style>
+          <a:lnRef idx="1">
+            <a:schemeClr val="accent1"/>
+          </a:lnRef>
+          <a:fillRef idx="3">
+            <a:schemeClr val="accent1"/>
+          </a:fillRef>
+          <a:effectRef idx="2">
+            <a:schemeClr val="accent1"/>
+          </a:effectRef>
+          <a:fontRef idx="minor">
+            <a:schemeClr val="lt1"/>
+          </a:fontRef>
+        </p:style>
+        <p:txBody>
+          <a:bodyPr rtlCol="0" anchor="ctr"/>
+          <a:lstStyle/>
+          <a:p>
+            <a:pPr algn="ctr"/>
+          </a:p>
+        </p:txBody>
+      </p:sp>
+      <p:sp>
+        <p:nvSpPr>
+          <p:cNvPr id="26" name="TextBox 25"/>
+          <p:cNvSpPr txBox="1"/>
+          <p:nvPr/>
+        </p:nvSpPr>
+        <p:spPr>
+          <a:xfrm>
+            <a:off x="8083296" y="3575304"/>
+            <a:ext cx="3291840" cy="283464"/>
+          </a:xfrm>
+          <a:prstGeom prst="rect">
+            <a:avLst/>
+          </a:prstGeom>
+          <a:noFill/>
+        </p:spPr>
+        <p:txBody>
+          <a:bodyPr wrap="square" lIns="0" rIns="0" tIns="0" bIns="0">
+            <a:spAutoFit/>
+          </a:bodyPr>
+          <a:lstStyle/>
+          <a:p>
+            <a:pPr>
+              <a:spcAft>
+                <a:spcPts val="800"/>
+              </a:spcAft>
+              <a:defRPr sz="1800" b="1">
+                <a:solidFill>
+                  <a:srgbClr val="173653"/>
+                </a:solidFill>
+                <a:latin typeface="Aptos"/>
+              </a:defRPr>
+            </a:pPr>
+            <a:r>
+              <a:t>Comparar y distribuir</a:t>
+            </a:r>
+          </a:p>
+        </p:txBody>
+      </p:sp>
+      <p:sp>
+        <p:nvSpPr>
+          <p:cNvPr id="27" name="TextBox 26"/>
+          <p:cNvSpPr txBox="1"/>
+          <p:nvPr/>
+        </p:nvSpPr>
+        <p:spPr>
+          <a:xfrm>
+            <a:off x="8083296" y="3941064"/>
+            <a:ext cx="3291840" cy="530352"/>
+          </a:xfrm>
+          <a:prstGeom prst="rect">
+            <a:avLst/>
+          </a:prstGeom>
+          <a:noFill/>
+        </p:spPr>
+        <p:txBody>
+          <a:bodyPr wrap="square" lIns="0" rIns="0" tIns="0" bIns="0">
+            <a:spAutoFit/>
+          </a:bodyPr>
+          <a:lstStyle/>
+          <a:p>
+            <a:pPr>
+              <a:spcAft>
+                <a:spcPts val="800"/>
+              </a:spcAft>
+              <a:defRPr sz="1300" b="0">
+                <a:solidFill>
+                  <a:srgbClr val="31566F"/>
+                </a:solidFill>
+                <a:latin typeface="Aptos"/>
+              </a:defRPr>
+            </a:pPr>
+            <a:r>
+              <a:t>Dos o más meses; horas por Grupo y Técnico con los mismos filtros.</a:t>
+            </a:r>
+          </a:p>
+        </p:txBody>
+      </p:sp>
+      <p:sp>
+        <p:nvSpPr>
+          <p:cNvPr id="28" name="Rounded Rectangle 27"/>
+          <p:cNvSpPr/>
+          <p:nvPr/>
+        </p:nvSpPr>
+        <p:spPr>
+          <a:xfrm>
+            <a:off x="7872983" y="4672584"/>
+            <a:ext cx="3730752" cy="1069848"/>
+          </a:xfrm>
+          <a:prstGeom prst="roundRect">
+            <a:avLst>
+              <a:gd name="adj" fmla="val 12000"/>
+            </a:avLst>
+          </a:prstGeom>
+          <a:solidFill>
+            <a:srgbClr val="F5F9FC"/>
+          </a:solidFill>
+          <a:ln>
+            <a:solidFill>
+              <a:srgbClr val="DFE9F0"/>
+            </a:solidFill>
+          </a:ln>
+        </p:spPr>
+        <p:style>
+          <a:lnRef idx="1">
+            <a:schemeClr val="accent1"/>
+          </a:lnRef>
+          <a:fillRef idx="3">
+            <a:schemeClr val="accent1"/>
+          </a:fillRef>
+          <a:effectRef idx="2">
+            <a:schemeClr val="accent1"/>
+          </a:effectRef>
+          <a:fontRef idx="minor">
+            <a:schemeClr val="lt1"/>
+          </a:fontRef>
+        </p:style>
+        <p:txBody>
+          <a:bodyPr rtlCol="0" anchor="ctr"/>
+          <a:lstStyle/>
+          <a:p>
+            <a:pPr algn="ctr"/>
+          </a:p>
+        </p:txBody>
+      </p:sp>
+      <p:sp>
+        <p:nvSpPr>
+          <p:cNvPr id="29" name="TextBox 28"/>
+          <p:cNvSpPr txBox="1"/>
+          <p:nvPr/>
+        </p:nvSpPr>
+        <p:spPr>
+          <a:xfrm>
+            <a:off x="8083296" y="4800600"/>
+            <a:ext cx="3291840" cy="283464"/>
+          </a:xfrm>
+          <a:prstGeom prst="rect">
+            <a:avLst/>
+          </a:prstGeom>
+          <a:noFill/>
+        </p:spPr>
+        <p:txBody>
+          <a:bodyPr wrap="square" lIns="0" rIns="0" tIns="0" bIns="0">
+            <a:spAutoFit/>
+          </a:bodyPr>
+          <a:lstStyle/>
+          <a:p>
+            <a:pPr>
+              <a:spcAft>
+                <a:spcPts val="800"/>
+              </a:spcAft>
+              <a:defRPr sz="1800" b="1">
+                <a:solidFill>
+                  <a:srgbClr val="173653"/>
+                </a:solidFill>
+                <a:latin typeface="Aptos"/>
+              </a:defRPr>
+            </a:pPr>
+            <a:r>
+              <a:t>Consultar y exportar</a:t>
+            </a:r>
+          </a:p>
+        </p:txBody>
+      </p:sp>
+      <p:sp>
+        <p:nvSpPr>
+          <p:cNvPr id="30" name="TextBox 29"/>
+          <p:cNvSpPr txBox="1"/>
+          <p:nvPr/>
+        </p:nvSpPr>
+        <p:spPr>
+          <a:xfrm>
+            <a:off x="8083296" y="5166360"/>
+            <a:ext cx="3291840" cy="530352"/>
+          </a:xfrm>
+          <a:prstGeom prst="rect">
+            <a:avLst/>
+          </a:prstGeom>
+          <a:noFill/>
+        </p:spPr>
+        <p:txBody>
+          <a:bodyPr wrap="square" lIns="0" rIns="0" tIns="0" bIns="0">
+            <a:spAutoFit/>
+          </a:bodyPr>
+          <a:lstStyle/>
+          <a:p>
+            <a:pPr>
+              <a:spcAft>
+                <a:spcPts val="800"/>
+              </a:spcAft>
+              <a:defRPr sz="1300" b="0">
+                <a:solidFill>
+                  <a:srgbClr val="31566F"/>
+                </a:solidFill>
+                <a:latin typeface="Aptos"/>
+              </a:defRPr>
+            </a:pPr>
+            <a:r>
+              <a:t>Historial, detalle y Excel para revisar las horas aprobadas.</a:t>
+            </a:r>
+          </a:p>
+        </p:txBody>
+      </p:sp>
+      <p:sp>
+        <p:nvSpPr>
+          <p:cNvPr id="31" name="Rounded Rectangle 30"/>
+          <p:cNvSpPr/>
+          <p:nvPr/>
+        </p:nvSpPr>
+        <p:spPr>
+          <a:xfrm>
+            <a:off x="557784" y="5916168"/>
+            <a:ext cx="11045952" cy="338328"/>
+          </a:xfrm>
+          <a:prstGeom prst="roundRect">
+            <a:avLst>
+              <a:gd name="adj" fmla="val 12000"/>
+            </a:avLst>
+          </a:prstGeom>
+          <a:solidFill>
+            <a:srgbClr val="ECF7F6"/>
+          </a:solidFill>
+          <a:ln>
+            <a:noFill/>
+          </a:ln>
+        </p:spPr>
+        <p:style>
+          <a:lnRef idx="1">
+            <a:schemeClr val="accent1"/>
+          </a:lnRef>
+          <a:fillRef idx="3">
+            <a:schemeClr val="accent1"/>
+          </a:fillRef>
+          <a:effectRef idx="2">
+            <a:schemeClr val="accent1"/>
+          </a:effectRef>
+          <a:fontRef idx="minor">
+            <a:schemeClr val="lt1"/>
+          </a:fontRef>
+        </p:style>
+        <p:txBody>
+          <a:bodyPr rtlCol="0" anchor="ctr"/>
+          <a:lstStyle/>
+          <a:p>
+            <a:pPr algn="ctr"/>
+          </a:p>
+        </p:txBody>
+      </p:sp>
+      <p:sp>
+        <p:nvSpPr>
+          <p:cNvPr id="32" name="TextBox 31"/>
+          <p:cNvSpPr txBox="1"/>
+          <p:nvPr/>
+        </p:nvSpPr>
+        <p:spPr>
+          <a:xfrm>
+            <a:off x="731520" y="5989320"/>
+            <a:ext cx="10698480" cy="192024"/>
+          </a:xfrm>
+          <a:prstGeom prst="rect">
+            <a:avLst/>
+          </a:prstGeom>
+          <a:noFill/>
+        </p:spPr>
+        <p:txBody>
+          <a:bodyPr wrap="square" lIns="0" rIns="0" tIns="0" bIns="0">
+            <a:spAutoFit/>
+          </a:bodyPr>
+          <a:lstStyle/>
+          <a:p>
+            <a:pPr>
+              <a:spcAft>
+                <a:spcPts val="800"/>
+              </a:spcAft>
+              <a:defRPr sz="1300" b="1">
+                <a:solidFill>
+                  <a:srgbClr val="168F94"/>
+                </a:solidFill>
+                <a:latin typeface="Aptos"/>
+              </a:defRPr>
+            </a:pPr>
+            <a:r>
+              <a:t>Los pendientes y rechazados no suman horas a los indicadores.</a:t>
             </a:r>
           </a:p>
         </p:txBody>

</xml_diff>